<commit_message>
Argumentarium auf neue Scope kürzen — Scharnierformat-Fokus
- _build_xml-vorteile.py: PDF auf eine A4-Seite reduziert; nur Titel,
  Untertitel «XML als Scharnier für den Abgleich von Rechtsdokumenten»
  und Sinn-und-Zweck-Abschnitt aus Scope_neu_26.04.2026.txt.
- _build_xml-vorteile-pptx.py: PowerPoint auf 6 Folien gekürzt
  (Titel, Abschnittsüberschrift, Bezüge, Mapping, Kernaussage, Danke).
- Vergleichsblock PDF/DOCX/XML samt Tabelle und Schwächen-Listen
  vollständig entfernt.
- xml-vorteile-{pdf,pptx,folien.pdf} neu generiert; alte Versionen
  als xml-vorteile-alt.* zur Referenz aufbewahrt.

Co-Authored-By: Claude Opus 4.7 (1M context) <noreply@anthropic.com>
</commit_message>
<xml_diff>
--- a/Beispiele/sebastian/xml-vorteile.pptx
+++ b/Beispiele/sebastian/xml-vorteile.pptx
@@ -17,14 +17,6 @@
     <p:sldId id="259" r:id="rId4"/>
     <p:sldId id="260" r:id="rId3"/>
     <p:sldId id="261" r:id="rId2"/>
-    <p:sldId id="262" r:id="rId14"/>
-    <p:sldId id="263" r:id="rId15"/>
-    <p:sldId id="264" r:id="rId16"/>
-    <p:sldId id="265" r:id="rId17"/>
-    <p:sldId id="266" r:id="rId18"/>
-    <p:sldId id="267" r:id="rId19"/>
-    <p:sldId id="268" r:id="rId20"/>
-    <p:sldId id="269" r:id="rId21"/>
   </p:sldIdLst>
   <p:sldSz cx="12192000" cy="6858000"/>
   <p:notesSz cx="9144000" cy="6858000"/>
@@ -4047,7 +4039,7 @@
                   <a:srgbClr val="38B07D"/>
                 </a:solidFill>
               </a:rPr>
-              <a:t>XML statt PDF/DOCX</a:t>
+              <a:t>Strukturierte Rechtsdokumente</a:t>
             </a:r>
           </a:p>
         </p:txBody>
@@ -4069,518 +4061,16 @@
           <a:p>
             <a:pPr algn="l"/>
             <a:r>
-              <a:rPr sz="2200" b="0">
+              <a:rPr sz="2000" b="0">
                 <a:solidFill>
                   <a:srgbClr val="212121"/>
                 </a:solidFill>
               </a:rPr>
-              <a:t>Strukturierte Rechtsdokumente — ein Argumentarium</a:t>
-            </a:r>
-          </a:p>
-        </p:txBody>
-      </p:sp>
-    </p:spTree>
-  </p:cSld>
-  <p:clrMapOvr>
-    <a:masterClrMapping/>
-  </p:clrMapOvr>
-</p:sld>
-</file>
-
-<file path=ppt/slides/slide10.xml><?xml version="1.0" encoding="utf-8"?>
-<p:sld xmlns:a="http://schemas.openxmlformats.org/drawingml/2006/main" xmlns:p="http://schemas.openxmlformats.org/presentationml/2006/main" xmlns:r="http://schemas.openxmlformats.org/officeDocument/2006/relationships">
-  <p:cSld>
-    <p:spTree>
-      <p:nvGrpSpPr>
-        <p:cNvPr id="1" name=""/>
-        <p:cNvGrpSpPr/>
-        <p:nvPr/>
-      </p:nvGrpSpPr>
-      <p:grpSpPr/>
-      <p:sp>
-        <p:nvSpPr>
-          <p:cNvPr id="2" name="Title 1"/>
-          <p:cNvSpPr>
-            <a:spLocks noGrp="1"/>
-          </p:cNvSpPr>
-          <p:nvPr>
-            <p:ph type="title"/>
-          </p:nvPr>
-        </p:nvSpPr>
-        <p:spPr/>
-        <p:txBody>
-          <a:bodyPr/>
-          <a:lstStyle/>
-          <a:p>
-            <a:pPr algn="l"/>
-            <a:r>
-              <a:rPr sz="2800" b="1">
-                <a:solidFill>
-                  <a:srgbClr val="38B07D"/>
-                </a:solidFill>
-              </a:rPr>
-              <a:t>Sieben operative Vorteile</a:t>
-            </a:r>
-          </a:p>
-        </p:txBody>
-      </p:sp>
-      <p:sp>
-        <p:nvSpPr>
-          <p:cNvPr id="3" name="Content Placeholder 2"/>
-          <p:cNvSpPr>
-            <a:spLocks noGrp="1"/>
-          </p:cNvSpPr>
-          <p:nvPr>
-            <p:ph idx="1"/>
-          </p:nvPr>
-        </p:nvSpPr>
-        <p:spPr/>
-        <p:txBody>
-          <a:bodyPr/>
-          <a:lstStyle/>
-          <a:p/>
-        </p:txBody>
-      </p:sp>
-      <p:sp>
-        <p:nvSpPr>
-          <p:cNvPr id="4" name="Text Placeholder 3"/>
-          <p:cNvSpPr>
-            <a:spLocks noGrp="1"/>
-          </p:cNvSpPr>
-          <p:nvPr>
-            <p:ph type="body" idx="2" sz="half"/>
-          </p:nvPr>
-        </p:nvSpPr>
-        <p:spPr/>
-        <p:txBody>
-          <a:bodyPr wrap="square"/>
-          <a:lstStyle/>
-          <a:p>
-            <a:pPr/>
-            <a:r>
-              <a:rPr sz="1600">
-                <a:solidFill>
-                  <a:srgbClr val="212121"/>
-                </a:solidFill>
-              </a:rPr>
-              <a:t>Maschinell auswertbar ohne Heuristik (XPath statt OCR-Regex).</a:t>
-            </a:r>
-          </a:p>
-          <a:p>
-            <a:pPr/>
-            <a:r>
-              <a:rPr sz="1600">
-                <a:solidFill>
-                  <a:srgbClr val="212121"/>
-                </a:solidFill>
-              </a:rPr>
-              <a:t>Verlustfreie Beziehungen (Vorinstanz, Weiterzug, Zitate).</a:t>
-            </a:r>
-          </a:p>
-          <a:p>
-            <a:pPr/>
-            <a:r>
-              <a:rPr sz="1600">
-                <a:solidFill>
-                  <a:srgbClr val="212121"/>
-                </a:solidFill>
-              </a:rPr>
-              <a:t>Validierung vor dem Versand (Pflichtfelder, Geschäftsnummer-Format).</a:t>
-            </a:r>
-          </a:p>
-          <a:p>
-            <a:pPr/>
-            <a:r>
-              <a:rPr sz="1600">
-                <a:solidFill>
-                  <a:srgbClr val="212121"/>
-                </a:solidFill>
-              </a:rPr>
-              <a:t>Mehrere Darstellungen aus einer Quelle (PDF, HTML, JSON, TXT).</a:t>
-            </a:r>
-          </a:p>
-          <a:p>
-            <a:pPr/>
-            <a:r>
-              <a:rPr sz="1600">
-                <a:solidFill>
-                  <a:srgbClr val="212121"/>
-                </a:solidFill>
-              </a:rPr>
-              <a:t>Versionierung mit Diff-Sinn — inhaltliche Änderungen sichtbar.</a:t>
-            </a:r>
-          </a:p>
-          <a:p>
-            <a:pPr/>
-            <a:r>
-              <a:rPr sz="1600">
-                <a:solidFill>
-                  <a:srgbClr val="212121"/>
-                </a:solidFill>
-              </a:rPr>
-              <a:t>Anonymisierung als Datenfeld (steuerbar, maschinell prüfbar).</a:t>
-            </a:r>
-          </a:p>
-          <a:p>
-            <a:pPr/>
-            <a:r>
-              <a:rPr sz="1600">
-                <a:solidFill>
-                  <a:srgbClr val="212121"/>
-                </a:solidFill>
-              </a:rPr>
-              <a:t>Stabile Anker für Querverweise (überleben Textänderungen).</a:t>
-            </a:r>
-          </a:p>
-        </p:txBody>
-      </p:sp>
-    </p:spTree>
-  </p:cSld>
-  <p:clrMapOvr>
-    <a:masterClrMapping/>
-  </p:clrMapOvr>
-</p:sld>
-</file>
-
-<file path=ppt/slides/slide11.xml><?xml version="1.0" encoding="utf-8"?>
-<p:sld xmlns:a="http://schemas.openxmlformats.org/drawingml/2006/main" xmlns:p="http://schemas.openxmlformats.org/presentationml/2006/main" xmlns:r="http://schemas.openxmlformats.org/officeDocument/2006/relationships">
-  <p:cSld>
-    <p:spTree>
-      <p:nvGrpSpPr>
-        <p:cNvPr id="1" name=""/>
-        <p:cNvGrpSpPr/>
-        <p:nvPr/>
-      </p:nvGrpSpPr>
-      <p:grpSpPr/>
-      <p:sp>
-        <p:nvSpPr>
-          <p:cNvPr id="2" name="Title 1"/>
-          <p:cNvSpPr>
-            <a:spLocks noGrp="1"/>
-          </p:cNvSpPr>
-          <p:nvPr>
-            <p:ph type="title"/>
-          </p:nvPr>
-        </p:nvSpPr>
-        <p:spPr/>
-        <p:txBody>
-          <a:bodyPr/>
-          <a:lstStyle/>
-          <a:p>
-            <a:pPr algn="l"/>
-            <a:r>
-              <a:rPr sz="2800" b="1">
-                <a:solidFill>
-                  <a:srgbClr val="38B07D"/>
-                </a:solidFill>
-              </a:rPr>
-              <a:t>Strategischer Mehrwert</a:t>
-            </a:r>
-          </a:p>
-        </p:txBody>
-      </p:sp>
-      <p:sp>
-        <p:nvSpPr>
-          <p:cNvPr id="3" name="Content Placeholder 2"/>
-          <p:cNvSpPr>
-            <a:spLocks noGrp="1"/>
-          </p:cNvSpPr>
-          <p:nvPr>
-            <p:ph idx="1"/>
-          </p:nvPr>
-        </p:nvSpPr>
-        <p:spPr/>
-        <p:txBody>
-          <a:bodyPr/>
-          <a:lstStyle/>
-          <a:p/>
-        </p:txBody>
-      </p:sp>
-      <p:sp>
-        <p:nvSpPr>
-          <p:cNvPr id="4" name="Text Placeholder 3"/>
-          <p:cNvSpPr>
-            <a:spLocks noGrp="1"/>
-          </p:cNvSpPr>
-          <p:nvPr>
-            <p:ph type="body" idx="2" sz="half"/>
-          </p:nvPr>
-        </p:nvSpPr>
-        <p:spPr/>
-        <p:txBody>
-          <a:bodyPr wrap="square"/>
-          <a:lstStyle/>
-          <a:p>
-            <a:pPr/>
-            <a:r>
-              <a:rPr sz="1800">
-                <a:solidFill>
-                  <a:srgbClr val="212121"/>
-                </a:solidFill>
-              </a:rPr>
-              <a:t>Statistische Auswertbarkeit über Korpora.</a:t>
-            </a:r>
-          </a:p>
-          <a:p>
-            <a:pPr/>
-            <a:r>
-              <a:rPr sz="1800">
-                <a:solidFill>
-                  <a:srgbClr val="212121"/>
-                </a:solidFill>
-              </a:rPr>
-              <a:t>KI-Tauglichkeit (hochwertige Trainingsgrundlage).</a:t>
-            </a:r>
-          </a:p>
-          <a:p>
-            <a:pPr/>
-            <a:r>
-              <a:rPr sz="1800">
-                <a:solidFill>
-                  <a:srgbClr val="212121"/>
-                </a:solidFill>
-              </a:rPr>
-              <a:t>Anschluss an eJustiz-Standards (Akoma Ntoso, Justitia 4.0).</a:t>
-            </a:r>
-          </a:p>
-          <a:p>
-            <a:pPr/>
-            <a:r>
-              <a:rPr sz="1800">
-                <a:solidFill>
-                  <a:srgbClr val="212121"/>
-                </a:solidFill>
-              </a:rPr>
-              <a:t>Langzeitarchivierung — offen, herstellerunabhängig.</a:t>
-            </a:r>
-          </a:p>
-          <a:p>
-            <a:pPr/>
-            <a:r>
-              <a:rPr sz="1800">
-                <a:solidFill>
-                  <a:srgbClr val="212121"/>
-                </a:solidFill>
-              </a:rPr>
-              <a:t>Kanzleiweite Konsistenz durch erzwungene Pflichtfelder.</a:t>
-            </a:r>
-          </a:p>
-        </p:txBody>
-      </p:sp>
-    </p:spTree>
-  </p:cSld>
-  <p:clrMapOvr>
-    <a:masterClrMapping/>
-  </p:clrMapOvr>
-</p:sld>
-</file>
-
-<file path=ppt/slides/slide12.xml><?xml version="1.0" encoding="utf-8"?>
-<p:sld xmlns:a="http://schemas.openxmlformats.org/drawingml/2006/main" xmlns:p="http://schemas.openxmlformats.org/presentationml/2006/main" xmlns:r="http://schemas.openxmlformats.org/officeDocument/2006/relationships">
-  <p:cSld>
-    <p:spTree>
-      <p:nvGrpSpPr>
-        <p:cNvPr id="1" name=""/>
-        <p:cNvGrpSpPr/>
-        <p:nvPr/>
-      </p:nvGrpSpPr>
-      <p:grpSpPr/>
-      <p:sp>
-        <p:nvSpPr>
-          <p:cNvPr id="2" name="Title 1"/>
-          <p:cNvSpPr>
-            <a:spLocks noGrp="1"/>
-          </p:cNvSpPr>
-          <p:nvPr>
-            <p:ph type="title"/>
-          </p:nvPr>
-        </p:nvSpPr>
-        <p:spPr/>
-        <p:txBody>
-          <a:bodyPr/>
-          <a:lstStyle/>
-          <a:p>
-            <a:pPr algn="l"/>
-            <a:r>
-              <a:rPr sz="2800" b="1">
-                <a:solidFill>
-                  <a:srgbClr val="38B07D"/>
-                </a:solidFill>
-              </a:rPr>
-              <a:t>Was XML nicht ist</a:t>
-            </a:r>
-          </a:p>
-        </p:txBody>
-      </p:sp>
-      <p:sp>
-        <p:nvSpPr>
-          <p:cNvPr id="3" name="Content Placeholder 2"/>
-          <p:cNvSpPr>
-            <a:spLocks noGrp="1"/>
-          </p:cNvSpPr>
-          <p:nvPr>
-            <p:ph idx="1"/>
-          </p:nvPr>
-        </p:nvSpPr>
-        <p:spPr/>
-        <p:txBody>
-          <a:bodyPr/>
-          <a:lstStyle/>
-          <a:p/>
-        </p:txBody>
-      </p:sp>
-      <p:sp>
-        <p:nvSpPr>
-          <p:cNvPr id="4" name="Text Placeholder 3"/>
-          <p:cNvSpPr>
-            <a:spLocks noGrp="1"/>
-          </p:cNvSpPr>
-          <p:nvPr>
-            <p:ph type="body" idx="2" sz="half"/>
-          </p:nvPr>
-        </p:nvSpPr>
-        <p:spPr/>
-        <p:txBody>
-          <a:bodyPr wrap="square"/>
-          <a:lstStyle/>
-          <a:p>
-            <a:pPr/>
-            <a:r>
-              <a:rPr sz="1800">
-                <a:solidFill>
-                  <a:srgbClr val="212121"/>
-                </a:solidFill>
-              </a:rPr>
-              <a:t>Kein Lesedokument — braucht Viewer oder generierte Ansicht.</a:t>
-            </a:r>
-          </a:p>
-          <a:p>
-            <a:pPr/>
-            <a:r>
-              <a:rPr sz="1800">
-                <a:solidFill>
-                  <a:srgbClr val="212121"/>
-                </a:solidFill>
-              </a:rPr>
-              <a:t>Kein Schreibwerkzeug — Editor erzeugt XML im Hintergrund.</a:t>
-            </a:r>
-          </a:p>
-          <a:p>
-            <a:pPr/>
-            <a:r>
-              <a:rPr sz="1800">
-                <a:solidFill>
-                  <a:srgbClr val="212121"/>
-                </a:solidFill>
-              </a:rPr>
-              <a:t>Kein Layout-Format — PDF wird weiter gebraucht, aber generiert aus XML.</a:t>
-            </a:r>
-          </a:p>
-          <a:p>
-            <a:pPr/>
-            <a:r>
-              <a:rPr sz="1800">
-                <a:solidFill>
-                  <a:srgbClr val="212121"/>
-                </a:solidFill>
-              </a:rPr>
-              <a:t>Kein Allheilmittel für bildhafte Beilagen (Pläne, Fotos, Gutachten).</a:t>
-            </a:r>
-          </a:p>
-        </p:txBody>
-      </p:sp>
-    </p:spTree>
-  </p:cSld>
-  <p:clrMapOvr>
-    <a:masterClrMapping/>
-  </p:clrMapOvr>
-</p:sld>
-</file>
-
-<file path=ppt/slides/slide13.xml><?xml version="1.0" encoding="utf-8"?>
-<p:sld xmlns:a="http://schemas.openxmlformats.org/drawingml/2006/main" xmlns:p="http://schemas.openxmlformats.org/presentationml/2006/main" xmlns:r="http://schemas.openxmlformats.org/officeDocument/2006/relationships">
-  <p:cSld>
-    <p:spTree>
-      <p:nvGrpSpPr>
-        <p:cNvPr id="1" name=""/>
-        <p:cNvGrpSpPr/>
-        <p:nvPr/>
-      </p:nvGrpSpPr>
-      <p:grpSpPr/>
-      <p:sp>
-        <p:nvSpPr>
-          <p:cNvPr id="2" name="Text Placeholder 1"/>
-          <p:cNvSpPr>
-            <a:spLocks noGrp="1"/>
-          </p:cNvSpPr>
-          <p:nvPr>
-            <p:ph type="body" idx="14" sz="quarter"/>
-          </p:nvPr>
-        </p:nvSpPr>
-        <p:spPr/>
-        <p:txBody>
-          <a:bodyPr/>
-          <a:lstStyle/>
-          <a:p>
-            <a:pPr algn="ctr"/>
-            <a:r>
-              <a:rPr sz="3600" b="1">
-                <a:solidFill>
-                  <a:srgbClr val="38B07D"/>
-                </a:solidFill>
-              </a:rPr>
-              <a:t>XML als Quellformat,</a:t>
-            </a:r>
-          </a:p>
-          <a:p>
-            <a:pPr algn="ctr"/>
-            <a:r>
-              <a:rPr sz="3600" b="1">
-                <a:solidFill>
-                  <a:srgbClr val="38B07D"/>
-                </a:solidFill>
-              </a:rPr>
-              <a:t>PDF und DOCX als Ausgabeformate.</a:t>
-            </a:r>
-          </a:p>
-          <a:p>
-            <a:pPr algn="ctr"/>
-            <a:r>
-              <a:rPr sz="800"/>
-              <a:t/>
-            </a:r>
-          </a:p>
-          <a:p>
-            <a:pPr algn="ctr"/>
-            <a:r>
-              <a:rPr sz="1800">
-                <a:solidFill>
-                  <a:srgbClr val="555555"/>
-                </a:solidFill>
-              </a:rPr>
-              <a:t>Strukturierte Daten für maschinelle Anwendungsfälle, gewohntes Layout für die Akte.</a:t>
-            </a:r>
-          </a:p>
-        </p:txBody>
-      </p:sp>
-    </p:spTree>
-  </p:cSld>
-  <p:clrMapOvr>
-    <a:masterClrMapping/>
-  </p:clrMapOvr>
-</p:sld>
-</file>
-
-<file path=ppt/slides/slide14.xml><?xml version="1.0" encoding="utf-8"?>
-<p:sld xmlns:a="http://schemas.openxmlformats.org/drawingml/2006/main" xmlns:p="http://schemas.openxmlformats.org/presentationml/2006/main" xmlns:r="http://schemas.openxmlformats.org/officeDocument/2006/relationships">
-  <p:cSld>
-    <p:spTree>
-      <p:nvGrpSpPr>
-        <p:cNvPr id="1" name=""/>
-        <p:cNvGrpSpPr/>
-        <p:nvPr/>
-      </p:nvGrpSpPr>
-      <p:grpSpPr/>
+              <a:t>XML als Scharnier für den Abgleich von Rechtsdokumenten (Entscheide und Rechtsschriften)</a:t>
+            </a:r>
+          </a:p>
+        </p:txBody>
+      </p:sp>
     </p:spTree>
   </p:cSld>
   <p:clrMapOvr>
@@ -4601,82 +4091,27 @@
       <p:grpSpPr/>
       <p:sp>
         <p:nvSpPr>
-          <p:cNvPr id="2" name="Text Placeholder 1"/>
-          <p:cNvSpPr>
-            <a:spLocks noGrp="1"/>
-          </p:cNvSpPr>
-          <p:nvPr>
-            <p:ph type="body" idx="14" sz="quarter"/>
+          <p:cNvPr id="2" name="Title 1"/>
+          <p:cNvSpPr>
+            <a:spLocks noGrp="1"/>
+          </p:cNvSpPr>
+          <p:nvPr>
+            <p:ph type="title"/>
           </p:nvPr>
         </p:nvSpPr>
         <p:spPr/>
         <p:txBody>
-          <a:bodyPr wrap="square"/>
+          <a:bodyPr/>
           <a:lstStyle/>
           <a:p>
-            <a:pPr/>
-            <a:r>
-              <a:rPr sz="2000">
+            <a:pPr algn="l"/>
+            <a:r>
+              <a:rPr sz="3600" b="1">
                 <a:solidFill>
-                  <a:srgbClr val="212121"/>
+                  <a:srgbClr val="38B07D"/>
                 </a:solidFill>
               </a:rPr>
-              <a:t>Sinn und Zweck</a:t>
-            </a:r>
-          </a:p>
-          <a:p>
-            <a:pPr/>
-            <a:r>
-              <a:rPr sz="2000">
-                <a:solidFill>
-                  <a:srgbClr val="212121"/>
-                </a:solidFill>
-              </a:rPr>
-              <a:t>Drei Formate auf einen Blick</a:t>
-            </a:r>
-          </a:p>
-          <a:p>
-            <a:pPr/>
-            <a:r>
-              <a:rPr sz="2000">
-                <a:solidFill>
-                  <a:srgbClr val="212121"/>
-                </a:solidFill>
-              </a:rPr>
-              <a:t>Warum PDF und DOCX nicht reichen</a:t>
-            </a:r>
-          </a:p>
-          <a:p>
-            <a:pPr/>
-            <a:r>
-              <a:rPr sz="2000">
-                <a:solidFill>
-                  <a:srgbClr val="212121"/>
-                </a:solidFill>
-              </a:rPr>
-              <a:t>Vorteile von Domänen-XML</a:t>
-            </a:r>
-          </a:p>
-          <a:p>
-            <a:pPr/>
-            <a:r>
-              <a:rPr sz="2000">
-                <a:solidFill>
-                  <a:srgbClr val="212121"/>
-                </a:solidFill>
-              </a:rPr>
-              <a:t>Was XML nicht ist</a:t>
-            </a:r>
-          </a:p>
-          <a:p>
-            <a:pPr/>
-            <a:r>
-              <a:rPr sz="2000">
-                <a:solidFill>
-                  <a:srgbClr val="212121"/>
-                </a:solidFill>
-              </a:rPr>
-              <a:t>Faustregel</a:t>
+              <a:t>Sinn und Zweck — wieso ein strukturiertes Scharnierformat?</a:t>
             </a:r>
           </a:p>
         </p:txBody>
@@ -4716,12 +4151,100 @@
           <a:p>
             <a:pPr algn="l"/>
             <a:r>
-              <a:rPr sz="4400" b="1">
+              <a:rPr sz="2800" b="1">
                 <a:solidFill>
                   <a:srgbClr val="38B07D"/>
                 </a:solidFill>
               </a:rPr>
-              <a:t>Sinn und Zweck</a:t>
+              <a:t>Texte und ihre Bezüge</a:t>
+            </a:r>
+          </a:p>
+        </p:txBody>
+      </p:sp>
+      <p:sp>
+        <p:nvSpPr>
+          <p:cNvPr id="3" name="Content Placeholder 2"/>
+          <p:cNvSpPr>
+            <a:spLocks noGrp="1"/>
+          </p:cNvSpPr>
+          <p:nvPr>
+            <p:ph idx="1"/>
+          </p:nvPr>
+        </p:nvSpPr>
+        <p:spPr/>
+        <p:txBody>
+          <a:bodyPr/>
+          <a:lstStyle/>
+          <a:p/>
+        </p:txBody>
+      </p:sp>
+      <p:sp>
+        <p:nvSpPr>
+          <p:cNvPr id="4" name="Text Placeholder 3"/>
+          <p:cNvSpPr>
+            <a:spLocks noGrp="1"/>
+          </p:cNvSpPr>
+          <p:nvPr>
+            <p:ph type="body" idx="2" sz="half"/>
+          </p:nvPr>
+        </p:nvSpPr>
+        <p:spPr/>
+        <p:txBody>
+          <a:bodyPr wrap="square"/>
+          <a:lstStyle/>
+          <a:p>
+            <a:pPr/>
+            <a:r>
+              <a:rPr sz="1800">
+                <a:solidFill>
+                  <a:srgbClr val="212121"/>
+                </a:solidFill>
+              </a:rPr>
+              <a:t>Rechtsschriften und Urteile bestehen mehrheitlich aus Text.</a:t>
+            </a:r>
+          </a:p>
+          <a:p>
+            <a:pPr/>
+            <a:r>
+              <a:rPr sz="1800">
+                <a:solidFill>
+                  <a:srgbClr val="212121"/>
+                </a:solidFill>
+              </a:rPr>
+              <a:t>Im Verfahren werden diese Texte ausgetauscht; es wird wechselseitig auf Textteile Bezug genommen.</a:t>
+            </a:r>
+          </a:p>
+          <a:p>
+            <a:pPr/>
+            <a:r>
+              <a:rPr sz="1800">
+                <a:solidFill>
+                  <a:srgbClr val="212121"/>
+                </a:solidFill>
+              </a:rPr>
+              <a:t>Bezug nicht auf beliebige Stellen, sondern auf inhaltlich verwandte:</a:t>
+            </a:r>
+          </a:p>
+          <a:p>
+            <a:pPr lvl="1"/>
+            <a:r>
+              <a:rPr sz="1600">
+                <a:solidFill>
+                  <a:srgbClr val="212121"/>
+                </a:solidFill>
+              </a:rPr>
+              <a:t>Sachverhaltselemente korrespondieren mit Sachverhaltselementen,</a:t>
+            </a:r>
+          </a:p>
+          <a:p>
+            <a:pPr lvl="1"/>
+            <a:r>
+              <a:rPr sz="1600">
+                <a:solidFill>
+                  <a:srgbClr val="212121"/>
+                </a:solidFill>
+              </a:rPr>
+              <a:t>rechtliche Argumente werden gegen rechtliche Argumente erwidert.</a:t>
             </a:r>
           </a:p>
         </p:txBody>
@@ -4766,7 +4289,7 @@
                   <a:srgbClr val="38B07D"/>
                 </a:solidFill>
               </a:rPr>
-              <a:t>Wozu strukturierte Rechtsdokumente?</a:t>
+              <a:t>Mapping braucht minimale Struktur</a:t>
             </a:r>
           </a:p>
         </p:txBody>
@@ -4805,78 +4328,56 @@
           <a:p>
             <a:pPr/>
             <a:r>
-              <a:rPr sz="1600">
+              <a:rPr sz="1800">
                 <a:solidFill>
                   <a:srgbClr val="212121"/>
                 </a:solidFill>
               </a:rPr>
-              <a:t>Rechtsschriften und Urteile bestehen mehrheitlich aus Text.</a:t>
+              <a:t>Für den Austausch und Abgleich wird ein Mapping benötigt.</a:t>
             </a:r>
           </a:p>
           <a:p>
             <a:pPr/>
             <a:r>
-              <a:rPr sz="1600">
+              <a:rPr sz="1800">
                 <a:solidFill>
                   <a:srgbClr val="212121"/>
                 </a:solidFill>
               </a:rPr>
-              <a:t>Im Verfahren wird wechselseitig Bezug genommen — auf inhaltlich verwandte Stellen.</a:t>
-            </a:r>
-          </a:p>
-          <a:p>
-            <a:pPr lvl="1"/>
-            <a:r>
-              <a:rPr sz="1400">
+              <a:t>Für das Mapping ist eine minimale Struktur hilfreich.</a:t>
+            </a:r>
+          </a:p>
+          <a:p>
+            <a:pPr/>
+            <a:r>
+              <a:rPr sz="1800">
                 <a:solidFill>
                   <a:srgbClr val="212121"/>
                 </a:solidFill>
               </a:rPr>
-              <a:t>Sachverhaltselemente korrespondieren mit Sachverhaltselementen,</a:t>
-            </a:r>
-          </a:p>
-          <a:p>
-            <a:pPr lvl="1"/>
-            <a:r>
-              <a:rPr sz="1400">
+              <a:t>Unerheblich, ob Texte originär strukturiert entstehen oder aus PDF abgeleitet werden.</a:t>
+            </a:r>
+          </a:p>
+          <a:p>
+            <a:pPr/>
+            <a:r>
+              <a:rPr sz="1800">
                 <a:solidFill>
                   <a:srgbClr val="212121"/>
                 </a:solidFill>
               </a:rPr>
-              <a:t>rechtliche Argumente werden gegen rechtliche Argumente erwidert.</a:t>
+              <a:t>Entscheidend: typische Bezüge maschinell nachvollziehbar.</a:t>
             </a:r>
           </a:p>
           <a:p>
             <a:pPr/>
             <a:r>
-              <a:rPr sz="1600">
+              <a:rPr sz="1800">
                 <a:solidFill>
                   <a:srgbClr val="212121"/>
                 </a:solidFill>
               </a:rPr>
-              <a:t>Strukturierte Daten machen diese Bezüge maschinell nachvollziehbar.</a:t>
-            </a:r>
-          </a:p>
-          <a:p>
-            <a:pPr/>
-            <a:r>
-              <a:rPr sz="1600">
-                <a:solidFill>
-                  <a:srgbClr val="212121"/>
-                </a:solidFill>
-              </a:rPr>
-              <a:t>Strukturierung bewusst minimal — gerade so präzise wie nötig.</a:t>
-            </a:r>
-          </a:p>
-          <a:p>
-            <a:pPr/>
-            <a:r>
-              <a:rPr sz="1600">
-                <a:solidFill>
-                  <a:srgbClr val="212121"/>
-                </a:solidFill>
-              </a:rPr>
-              <a:t>Externe Ressourcen (Beweismittel, Akten) ebenfalls strukturiert verweisbar.</a:t>
+              <a:t>Strukturierung bewusst minimal — gerade so präzise wie nötig, nicht so detailliert wie möglich.</a:t>
             </a:r>
           </a:p>
         </p:txBody>
@@ -4901,12 +4402,12 @@
       <p:grpSpPr/>
       <p:sp>
         <p:nvSpPr>
-          <p:cNvPr id="2" name="Title 1"/>
-          <p:cNvSpPr>
-            <a:spLocks noGrp="1"/>
-          </p:cNvSpPr>
-          <p:nvPr>
-            <p:ph type="title"/>
+          <p:cNvPr id="2" name="Text Placeholder 1"/>
+          <p:cNvSpPr>
+            <a:spLocks noGrp="1"/>
+          </p:cNvSpPr>
+          <p:nvPr>
+            <p:ph type="body" idx="14" sz="quarter"/>
           </p:nvPr>
         </p:nvSpPr>
         <p:spPr/>
@@ -4914,682 +4415,47 @@
           <a:bodyPr/>
           <a:lstStyle/>
           <a:p>
-            <a:pPr algn="l"/>
-            <a:r>
-              <a:rPr sz="2800" b="1">
+            <a:pPr algn="ctr"/>
+            <a:r>
+              <a:rPr sz="3200" b="1">
                 <a:solidFill>
                   <a:srgbClr val="38B07D"/>
                 </a:solidFill>
               </a:rPr>
-              <a:t>Drei Formate auf einen Blick</a:t>
-            </a:r>
-          </a:p>
-        </p:txBody>
-      </p:sp>
-      <p:sp>
-        <p:nvSpPr>
-          <p:cNvPr id="3" name="Content Placeholder 2"/>
-          <p:cNvSpPr>
-            <a:spLocks noGrp="1"/>
-          </p:cNvSpPr>
-          <p:nvPr>
-            <p:ph idx="1"/>
-          </p:nvPr>
-        </p:nvSpPr>
-        <p:spPr/>
-        <p:txBody>
-          <a:bodyPr/>
-          <a:lstStyle/>
-          <a:p/>
-        </p:txBody>
-      </p:sp>
-      <p:sp>
-        <p:nvSpPr>
-          <p:cNvPr id="4" name="Text Placeholder 3"/>
-          <p:cNvSpPr>
-            <a:spLocks noGrp="1"/>
-          </p:cNvSpPr>
-          <p:nvPr>
-            <p:ph type="body" idx="2" sz="half"/>
-          </p:nvPr>
-        </p:nvSpPr>
-        <p:spPr/>
-        <p:txBody>
-          <a:bodyPr/>
-          <a:lstStyle/>
-          <a:p/>
-        </p:txBody>
-      </p:sp>
-      <p:graphicFrame>
-        <p:nvGraphicFramePr>
-          <p:cNvPr id="5" name="Table 4"/>
-          <p:cNvGraphicFramePr>
-            <a:graphicFrameLocks noGrp="1"/>
-          </p:cNvGraphicFramePr>
-          <p:nvPr/>
-        </p:nvGraphicFramePr>
-        <p:xfrm>
-          <a:off x="540000" y="1620000"/>
-          <a:ext cx="7920000" cy="3960000"/>
-        </p:xfrm>
-        <a:graphic>
-          <a:graphicData uri="http://schemas.openxmlformats.org/drawingml/2006/table">
-            <a:tbl>
-              <a:tblPr firstRow="1" bandRow="1">
-                <a:tableStyleId>{5C22544A-7EE6-4342-B048-85BDC9FD1C3A}</a:tableStyleId>
-              </a:tblPr>
-              <a:tblGrid>
-                <a:gridCol w="1980000"/>
-                <a:gridCol w="1980000"/>
-                <a:gridCol w="1980000"/>
-                <a:gridCol w="1980000"/>
-              </a:tblGrid>
-              <a:tr h="565714">
-                <a:tc>
-                  <a:txBody>
-                    <a:bodyPr/>
-                    <a:lstStyle/>
-                    <a:p>
-                      <a:r>
-                        <a:rPr sz="1100" b="1">
-                          <a:solidFill>
-                            <a:srgbClr val="FFFFFF"/>
-                          </a:solidFill>
-                        </a:rPr>
-                        <a:t/>
-                      </a:r>
-                    </a:p>
-                  </a:txBody>
-                  <a:tcPr>
-                    <a:solidFill>
-                      <a:srgbClr val="38B07D"/>
-                    </a:solidFill>
-                  </a:tcPr>
-                </a:tc>
-                <a:tc>
-                  <a:txBody>
-                    <a:bodyPr/>
-                    <a:lstStyle/>
-                    <a:p>
-                      <a:r>
-                        <a:rPr sz="1100" b="1">
-                          <a:solidFill>
-                            <a:srgbClr val="FFFFFF"/>
-                          </a:solidFill>
-                        </a:rPr>
-                        <a:t>PDF</a:t>
-                      </a:r>
-                    </a:p>
-                  </a:txBody>
-                  <a:tcPr>
-                    <a:solidFill>
-                      <a:srgbClr val="38B07D"/>
-                    </a:solidFill>
-                  </a:tcPr>
-                </a:tc>
-                <a:tc>
-                  <a:txBody>
-                    <a:bodyPr/>
-                    <a:lstStyle/>
-                    <a:p>
-                      <a:r>
-                        <a:rPr sz="1100" b="1">
-                          <a:solidFill>
-                            <a:srgbClr val="FFFFFF"/>
-                          </a:solidFill>
-                        </a:rPr>
-                        <a:t>DOCX</a:t>
-                      </a:r>
-                    </a:p>
-                  </a:txBody>
-                  <a:tcPr>
-                    <a:solidFill>
-                      <a:srgbClr val="38B07D"/>
-                    </a:solidFill>
-                  </a:tcPr>
-                </a:tc>
-                <a:tc>
-                  <a:txBody>
-                    <a:bodyPr/>
-                    <a:lstStyle/>
-                    <a:p>
-                      <a:r>
-                        <a:rPr sz="1100" b="1">
-                          <a:solidFill>
-                            <a:srgbClr val="FFFFFF"/>
-                          </a:solidFill>
-                        </a:rPr>
-                        <a:t>Domänen-XML</a:t>
-                      </a:r>
-                    </a:p>
-                  </a:txBody>
-                  <a:tcPr>
-                    <a:solidFill>
-                      <a:srgbClr val="38B07D"/>
-                    </a:solidFill>
-                  </a:tcPr>
-                </a:tc>
-              </a:tr>
-              <a:tr h="565714">
-                <a:tc>
-                  <a:txBody>
-                    <a:bodyPr/>
-                    <a:lstStyle/>
-                    <a:p>
-                      <a:r>
-                        <a:rPr sz="1000" b="1">
-                          <a:solidFill>
-                            <a:srgbClr val="212121"/>
-                          </a:solidFill>
-                        </a:rPr>
-                        <a:t>Modelliert</a:t>
-                      </a:r>
-                    </a:p>
-                  </a:txBody>
-                  <a:tcPr>
-                    <a:solidFill>
-                      <a:srgbClr val="FFFFFF"/>
-                    </a:solidFill>
-                  </a:tcPr>
-                </a:tc>
-                <a:tc>
-                  <a:txBody>
-                    <a:bodyPr/>
-                    <a:lstStyle/>
-                    <a:p>
-                      <a:r>
-                        <a:rPr sz="1000" b="0">
-                          <a:solidFill>
-                            <a:srgbClr val="212121"/>
-                          </a:solidFill>
-                        </a:rPr>
-                        <a:t>Pixel / Glyphen</a:t>
-                      </a:r>
-                    </a:p>
-                  </a:txBody>
-                  <a:tcPr>
-                    <a:solidFill>
-                      <a:srgbClr val="FFFFFF"/>
-                    </a:solidFill>
-                  </a:tcPr>
-                </a:tc>
-                <a:tc>
-                  <a:txBody>
-                    <a:bodyPr/>
-                    <a:lstStyle/>
-                    <a:p>
-                      <a:r>
-                        <a:rPr sz="1000" b="0">
-                          <a:solidFill>
-                            <a:srgbClr val="212121"/>
-                          </a:solidFill>
-                        </a:rPr>
-                        <a:t>Textverarbeitung (XML)</a:t>
-                      </a:r>
-                    </a:p>
-                  </a:txBody>
-                  <a:tcPr>
-                    <a:solidFill>
-                      <a:srgbClr val="FFFFFF"/>
-                    </a:solidFill>
-                  </a:tcPr>
-                </a:tc>
-                <a:tc>
-                  <a:txBody>
-                    <a:bodyPr/>
-                    <a:lstStyle/>
-                    <a:p>
-                      <a:r>
-                        <a:rPr sz="1000" b="0">
-                          <a:solidFill>
-                            <a:srgbClr val="212121"/>
-                          </a:solidFill>
-                        </a:rPr>
-                        <a:t>Juristische Inhalte</a:t>
-                      </a:r>
-                    </a:p>
-                  </a:txBody>
-                  <a:tcPr>
-                    <a:solidFill>
-                      <a:srgbClr val="FFFFFF"/>
-                    </a:solidFill>
-                  </a:tcPr>
-                </a:tc>
-              </a:tr>
-              <a:tr h="565714">
-                <a:tc>
-                  <a:txBody>
-                    <a:bodyPr/>
-                    <a:lstStyle/>
-                    <a:p>
-                      <a:r>
-                        <a:rPr sz="1000" b="1">
-                          <a:solidFill>
-                            <a:srgbClr val="212121"/>
-                          </a:solidFill>
-                        </a:rPr>
-                        <a:t>Schema</a:t>
-                      </a:r>
-                    </a:p>
-                  </a:txBody>
-                  <a:tcPr>
-                    <a:solidFill>
-                      <a:srgbClr val="F7F7F7"/>
-                    </a:solidFill>
-                  </a:tcPr>
-                </a:tc>
-                <a:tc>
-                  <a:txBody>
-                    <a:bodyPr/>
-                    <a:lstStyle/>
-                    <a:p>
-                      <a:r>
-                        <a:rPr sz="1000" b="0">
-                          <a:solidFill>
-                            <a:srgbClr val="212121"/>
-                          </a:solidFill>
-                        </a:rPr>
-                        <a:t>—</a:t>
-                      </a:r>
-                    </a:p>
-                  </a:txBody>
-                  <a:tcPr>
-                    <a:solidFill>
-                      <a:srgbClr val="F7F7F7"/>
-                    </a:solidFill>
-                  </a:tcPr>
-                </a:tc>
-                <a:tc>
-                  <a:txBody>
-                    <a:bodyPr/>
-                    <a:lstStyle/>
-                    <a:p>
-                      <a:r>
-                        <a:rPr sz="1000" b="0">
-                          <a:solidFill>
-                            <a:srgbClr val="212121"/>
-                          </a:solidFill>
-                        </a:rPr>
-                        <a:t>OOXML (Layout)</a:t>
-                      </a:r>
-                    </a:p>
-                  </a:txBody>
-                  <a:tcPr>
-                    <a:solidFill>
-                      <a:srgbClr val="F7F7F7"/>
-                    </a:solidFill>
-                  </a:tcPr>
-                </a:tc>
-                <a:tc>
-                  <a:txBody>
-                    <a:bodyPr/>
-                    <a:lstStyle/>
-                    <a:p>
-                      <a:r>
-                        <a:rPr sz="1000" b="0">
-                          <a:solidFill>
-                            <a:srgbClr val="212121"/>
-                          </a:solidFill>
-                        </a:rPr>
-                        <a:t>Eigen (Erwägung, …)</a:t>
-                      </a:r>
-                    </a:p>
-                  </a:txBody>
-                  <a:tcPr>
-                    <a:solidFill>
-                      <a:srgbClr val="F7F7F7"/>
-                    </a:solidFill>
-                  </a:tcPr>
-                </a:tc>
-              </a:tr>
-              <a:tr h="565714">
-                <a:tc>
-                  <a:txBody>
-                    <a:bodyPr/>
-                    <a:lstStyle/>
-                    <a:p>
-                      <a:r>
-                        <a:rPr sz="1000" b="1">
-                          <a:solidFill>
-                            <a:srgbClr val="212121"/>
-                          </a:solidFill>
-                        </a:rPr>
-                        <a:t>Validierbar</a:t>
-                      </a:r>
-                    </a:p>
-                  </a:txBody>
-                  <a:tcPr>
-                    <a:solidFill>
-                      <a:srgbClr val="FFFFFF"/>
-                    </a:solidFill>
-                  </a:tcPr>
-                </a:tc>
-                <a:tc>
-                  <a:txBody>
-                    <a:bodyPr/>
-                    <a:lstStyle/>
-                    <a:p>
-                      <a:r>
-                        <a:rPr sz="1000" b="0">
-                          <a:solidFill>
-                            <a:srgbClr val="212121"/>
-                          </a:solidFill>
-                        </a:rPr>
-                        <a:t>—</a:t>
-                      </a:r>
-                    </a:p>
-                  </a:txBody>
-                  <a:tcPr>
-                    <a:solidFill>
-                      <a:srgbClr val="FFFFFF"/>
-                    </a:solidFill>
-                  </a:tcPr>
-                </a:tc>
-                <a:tc>
-                  <a:txBody>
-                    <a:bodyPr/>
-                    <a:lstStyle/>
-                    <a:p>
-                      <a:r>
-                        <a:rPr sz="1000" b="0">
-                          <a:solidFill>
-                            <a:srgbClr val="212121"/>
-                          </a:solidFill>
-                        </a:rPr>
-                        <a:t>Layout-Struktur</a:t>
-                      </a:r>
-                    </a:p>
-                  </a:txBody>
-                  <a:tcPr>
-                    <a:solidFill>
-                      <a:srgbClr val="FFFFFF"/>
-                    </a:solidFill>
-                  </a:tcPr>
-                </a:tc>
-                <a:tc>
-                  <a:txBody>
-                    <a:bodyPr/>
-                    <a:lstStyle/>
-                    <a:p>
-                      <a:r>
-                        <a:rPr sz="1000" b="0">
-                          <a:solidFill>
-                            <a:srgbClr val="212121"/>
-                          </a:solidFill>
-                        </a:rPr>
-                        <a:t>Pflichtfelder, Formate</a:t>
-                      </a:r>
-                    </a:p>
-                  </a:txBody>
-                  <a:tcPr>
-                    <a:solidFill>
-                      <a:srgbClr val="FFFFFF"/>
-                    </a:solidFill>
-                  </a:tcPr>
-                </a:tc>
-              </a:tr>
-              <a:tr h="565714">
-                <a:tc>
-                  <a:txBody>
-                    <a:bodyPr/>
-                    <a:lstStyle/>
-                    <a:p>
-                      <a:r>
-                        <a:rPr sz="1000" b="1">
-                          <a:solidFill>
-                            <a:srgbClr val="212121"/>
-                          </a:solidFill>
-                        </a:rPr>
-                        <a:t>Maschinell auswertbar</a:t>
-                      </a:r>
-                    </a:p>
-                  </a:txBody>
-                  <a:tcPr>
-                    <a:solidFill>
-                      <a:srgbClr val="F7F7F7"/>
-                    </a:solidFill>
-                  </a:tcPr>
-                </a:tc>
-                <a:tc>
-                  <a:txBody>
-                    <a:bodyPr/>
-                    <a:lstStyle/>
-                    <a:p>
-                      <a:r>
-                        <a:rPr sz="1000" b="0">
-                          <a:solidFill>
-                            <a:srgbClr val="212121"/>
-                          </a:solidFill>
-                        </a:rPr>
-                        <a:t>Nur über OCR</a:t>
-                      </a:r>
-                    </a:p>
-                  </a:txBody>
-                  <a:tcPr>
-                    <a:solidFill>
-                      <a:srgbClr val="F7F7F7"/>
-                    </a:solidFill>
-                  </a:tcPr>
-                </a:tc>
-                <a:tc>
-                  <a:txBody>
-                    <a:bodyPr/>
-                    <a:lstStyle/>
-                    <a:p>
-                      <a:r>
-                        <a:rPr sz="1000" b="0">
-                          <a:solidFill>
-                            <a:srgbClr val="212121"/>
-                          </a:solidFill>
-                        </a:rPr>
-                        <a:t>Über Stilvorlagen</a:t>
-                      </a:r>
-                    </a:p>
-                  </a:txBody>
-                  <a:tcPr>
-                    <a:solidFill>
-                      <a:srgbClr val="F7F7F7"/>
-                    </a:solidFill>
-                  </a:tcPr>
-                </a:tc>
-                <a:tc>
-                  <a:txBody>
-                    <a:bodyPr/>
-                    <a:lstStyle/>
-                    <a:p>
-                      <a:r>
-                        <a:rPr sz="1000" b="0">
-                          <a:solidFill>
-                            <a:srgbClr val="212121"/>
-                          </a:solidFill>
-                        </a:rPr>
-                        <a:t>Direkt, eindeutig</a:t>
-                      </a:r>
-                    </a:p>
-                  </a:txBody>
-                  <a:tcPr>
-                    <a:solidFill>
-                      <a:srgbClr val="F7F7F7"/>
-                    </a:solidFill>
-                  </a:tcPr>
-                </a:tc>
-              </a:tr>
-              <a:tr h="565714">
-                <a:tc>
-                  <a:txBody>
-                    <a:bodyPr/>
-                    <a:lstStyle/>
-                    <a:p>
-                      <a:r>
-                        <a:rPr sz="1000" b="1">
-                          <a:solidFill>
-                            <a:srgbClr val="212121"/>
-                          </a:solidFill>
-                        </a:rPr>
-                        <a:t>Versionssichtbar</a:t>
-                      </a:r>
-                    </a:p>
-                  </a:txBody>
-                  <a:tcPr>
-                    <a:solidFill>
-                      <a:srgbClr val="FFFFFF"/>
-                    </a:solidFill>
-                  </a:tcPr>
-                </a:tc>
-                <a:tc>
-                  <a:txBody>
-                    <a:bodyPr/>
-                    <a:lstStyle/>
-                    <a:p>
-                      <a:r>
-                        <a:rPr sz="1000" b="0">
-                          <a:solidFill>
-                            <a:srgbClr val="212121"/>
-                          </a:solidFill>
-                        </a:rPr>
-                        <a:t>Nein</a:t>
-                      </a:r>
-                    </a:p>
-                  </a:txBody>
-                  <a:tcPr>
-                    <a:solidFill>
-                      <a:srgbClr val="FFFFFF"/>
-                    </a:solidFill>
-                  </a:tcPr>
-                </a:tc>
-                <a:tc>
-                  <a:txBody>
-                    <a:bodyPr/>
-                    <a:lstStyle/>
-                    <a:p>
-                      <a:r>
-                        <a:rPr sz="1000" b="0">
-                          <a:solidFill>
-                            <a:srgbClr val="212121"/>
-                          </a:solidFill>
-                        </a:rPr>
-                        <a:t>Binär (ZIP)</a:t>
-                      </a:r>
-                    </a:p>
-                  </a:txBody>
-                  <a:tcPr>
-                    <a:solidFill>
-                      <a:srgbClr val="FFFFFF"/>
-                    </a:solidFill>
-                  </a:tcPr>
-                </a:tc>
-                <a:tc>
-                  <a:txBody>
-                    <a:bodyPr/>
-                    <a:lstStyle/>
-                    <a:p>
-                      <a:r>
-                        <a:rPr sz="1000" b="0">
-                          <a:solidFill>
-                            <a:srgbClr val="212121"/>
-                          </a:solidFill>
-                        </a:rPr>
-                        <a:t>Zeile für Zeile</a:t>
-                      </a:r>
-                    </a:p>
-                  </a:txBody>
-                  <a:tcPr>
-                    <a:solidFill>
-                      <a:srgbClr val="FFFFFF"/>
-                    </a:solidFill>
-                  </a:tcPr>
-                </a:tc>
-              </a:tr>
-              <a:tr h="565716">
-                <a:tc>
-                  <a:txBody>
-                    <a:bodyPr/>
-                    <a:lstStyle/>
-                    <a:p>
-                      <a:r>
-                        <a:rPr sz="1000" b="1">
-                          <a:solidFill>
-                            <a:srgbClr val="212121"/>
-                          </a:solidFill>
-                        </a:rPr>
-                        <a:t>Langzeitlesbar</a:t>
-                      </a:r>
-                    </a:p>
-                  </a:txBody>
-                  <a:tcPr>
-                    <a:solidFill>
-                      <a:srgbClr val="F7F7F7"/>
-                    </a:solidFill>
-                  </a:tcPr>
-                </a:tc>
-                <a:tc>
-                  <a:txBody>
-                    <a:bodyPr/>
-                    <a:lstStyle/>
-                    <a:p>
-                      <a:r>
-                        <a:rPr sz="1000" b="0">
-                          <a:solidFill>
-                            <a:srgbClr val="212121"/>
-                          </a:solidFill>
-                        </a:rPr>
-                        <a:t>Versionsabhängig</a:t>
-                      </a:r>
-                    </a:p>
-                  </a:txBody>
-                  <a:tcPr>
-                    <a:solidFill>
-                      <a:srgbClr val="F7F7F7"/>
-                    </a:solidFill>
-                  </a:tcPr>
-                </a:tc>
-                <a:tc>
-                  <a:txBody>
-                    <a:bodyPr/>
-                    <a:lstStyle/>
-                    <a:p>
-                      <a:r>
-                        <a:rPr sz="1000" b="0">
-                          <a:solidFill>
-                            <a:srgbClr val="212121"/>
-                          </a:solidFill>
-                        </a:rPr>
-                        <a:t>OOXML offen, breit</a:t>
-                      </a:r>
-                    </a:p>
-                  </a:txBody>
-                  <a:tcPr>
-                    <a:solidFill>
-                      <a:srgbClr val="F7F7F7"/>
-                    </a:solidFill>
-                  </a:tcPr>
-                </a:tc>
-                <a:tc>
-                  <a:txBody>
-                    <a:bodyPr/>
-                    <a:lstStyle/>
-                    <a:p>
-                      <a:r>
-                        <a:rPr sz="1000" b="0">
-                          <a:solidFill>
-                            <a:srgbClr val="212121"/>
-                          </a:solidFill>
-                        </a:rPr>
-                        <a:t>Offen, schmal</a:t>
-                      </a:r>
-                    </a:p>
-                  </a:txBody>
-                  <a:tcPr>
-                    <a:solidFill>
-                      <a:srgbClr val="F7F7F7"/>
-                    </a:solidFill>
-                  </a:tcPr>
-                </a:tc>
-              </a:tr>
-            </a:tbl>
-          </a:graphicData>
-        </a:graphic>
-      </p:graphicFrame>
+              <a:t>Nicht Vollabbildung,</a:t>
+            </a:r>
+          </a:p>
+          <a:p>
+            <a:pPr algn="ctr"/>
+            <a:r>
+              <a:rPr sz="3200" b="1">
+                <a:solidFill>
+                  <a:srgbClr val="38B07D"/>
+                </a:solidFill>
+              </a:rPr>
+              <a:t>sondern Anker für den Abgleich.</a:t>
+            </a:r>
+          </a:p>
+          <a:p>
+            <a:pPr algn="ctr"/>
+            <a:r>
+              <a:rPr sz="800"/>
+              <a:t/>
+            </a:r>
+          </a:p>
+          <a:p>
+            <a:pPr algn="ctr"/>
+            <a:r>
+              <a:rPr sz="1600">
+                <a:solidFill>
+                  <a:srgbClr val="555555"/>
+                </a:solidFill>
+              </a:rPr>
+              <a:t>Ziel ist nicht, Rechtsschriften und Entscheide vollständig in strukturierter Form abzubilden.</a:t>
+            </a:r>
+          </a:p>
+        </p:txBody>
+      </p:sp>
     </p:spTree>
   </p:cSld>
   <p:clrMapOvr>
@@ -5608,355 +4474,6 @@
         <p:nvPr/>
       </p:nvGrpSpPr>
       <p:grpSpPr/>
-      <p:sp>
-        <p:nvSpPr>
-          <p:cNvPr id="2" name="Title 1"/>
-          <p:cNvSpPr>
-            <a:spLocks noGrp="1"/>
-          </p:cNvSpPr>
-          <p:nvPr>
-            <p:ph type="title"/>
-          </p:nvPr>
-        </p:nvSpPr>
-        <p:spPr/>
-        <p:txBody>
-          <a:bodyPr/>
-          <a:lstStyle/>
-          <a:p>
-            <a:pPr algn="l"/>
-            <a:r>
-              <a:rPr sz="3600" b="1">
-                <a:solidFill>
-                  <a:srgbClr val="38B07D"/>
-                </a:solidFill>
-              </a:rPr>
-              <a:t>Warum PDF und DOCX nicht reichen</a:t>
-            </a:r>
-          </a:p>
-        </p:txBody>
-      </p:sp>
-    </p:spTree>
-  </p:cSld>
-  <p:clrMapOvr>
-    <a:masterClrMapping/>
-  </p:clrMapOvr>
-</p:sld>
-</file>
-
-<file path=ppt/slides/slide7.xml><?xml version="1.0" encoding="utf-8"?>
-<p:sld xmlns:a="http://schemas.openxmlformats.org/drawingml/2006/main" xmlns:p="http://schemas.openxmlformats.org/presentationml/2006/main" xmlns:r="http://schemas.openxmlformats.org/officeDocument/2006/relationships">
-  <p:cSld>
-    <p:spTree>
-      <p:nvGrpSpPr>
-        <p:cNvPr id="1" name=""/>
-        <p:cNvGrpSpPr/>
-        <p:nvPr/>
-      </p:nvGrpSpPr>
-      <p:grpSpPr/>
-      <p:sp>
-        <p:nvSpPr>
-          <p:cNvPr id="2" name="Title 1"/>
-          <p:cNvSpPr>
-            <a:spLocks noGrp="1"/>
-          </p:cNvSpPr>
-          <p:nvPr>
-            <p:ph type="title"/>
-          </p:nvPr>
-        </p:nvSpPr>
-        <p:spPr/>
-        <p:txBody>
-          <a:bodyPr/>
-          <a:lstStyle/>
-          <a:p>
-            <a:pPr algn="l"/>
-            <a:r>
-              <a:rPr sz="2800" b="1">
-                <a:solidFill>
-                  <a:srgbClr val="38B07D"/>
-                </a:solidFill>
-              </a:rPr>
-              <a:t>PDF — Layout statt Inhalt</a:t>
-            </a:r>
-          </a:p>
-        </p:txBody>
-      </p:sp>
-      <p:sp>
-        <p:nvSpPr>
-          <p:cNvPr id="3" name="Content Placeholder 2"/>
-          <p:cNvSpPr>
-            <a:spLocks noGrp="1"/>
-          </p:cNvSpPr>
-          <p:nvPr>
-            <p:ph idx="1"/>
-          </p:nvPr>
-        </p:nvSpPr>
-        <p:spPr/>
-        <p:txBody>
-          <a:bodyPr/>
-          <a:lstStyle/>
-          <a:p/>
-        </p:txBody>
-      </p:sp>
-      <p:sp>
-        <p:nvSpPr>
-          <p:cNvPr id="4" name="Text Placeholder 3"/>
-          <p:cNvSpPr>
-            <a:spLocks noGrp="1"/>
-          </p:cNvSpPr>
-          <p:nvPr>
-            <p:ph type="body" idx="2" sz="half"/>
-          </p:nvPr>
-        </p:nvSpPr>
-        <p:spPr/>
-        <p:txBody>
-          <a:bodyPr wrap="square"/>
-          <a:lstStyle/>
-          <a:p>
-            <a:pPr/>
-            <a:r>
-              <a:rPr sz="1800">
-                <a:solidFill>
-                  <a:srgbClr val="212121"/>
-                </a:solidFill>
-              </a:rPr>
-              <a:t>Sandwich-PDFs: Bild + OCR-Textschicht — Diskrepanzen unbemerkt.</a:t>
-            </a:r>
-          </a:p>
-          <a:p>
-            <a:pPr/>
-            <a:r>
-              <a:rPr sz="1800">
-                <a:solidFill>
-                  <a:srgbClr val="212121"/>
-                </a:solidFill>
-              </a:rPr>
-              <a:t>Glyphen statt Bedeutung: «Erwägung Nr. 3» nur visuell erkennbar.</a:t>
-            </a:r>
-          </a:p>
-          <a:p>
-            <a:pPr/>
-            <a:r>
-              <a:rPr sz="1800">
-                <a:solidFill>
-                  <a:srgbClr val="212121"/>
-                </a:solidFill>
-              </a:rPr>
-              <a:t>Spezifikations-Unschärfe: dieselbe Information vielfältig darstellbar.</a:t>
-            </a:r>
-          </a:p>
-          <a:p>
-            <a:pPr/>
-            <a:r>
-              <a:rPr sz="1800">
-                <a:solidFill>
-                  <a:srgbClr val="212121"/>
-                </a:solidFill>
-              </a:rPr>
-              <a:t>Inhaltliche Validierung nicht vorgesehen.</a:t>
-            </a:r>
-          </a:p>
-          <a:p>
-            <a:pPr/>
-            <a:r>
-              <a:rPr sz="1800">
-                <a:solidFill>
-                  <a:srgbClr val="212121"/>
-                </a:solidFill>
-              </a:rPr>
-              <a:t>Hoher Metadaten-Anteil (Schriftarten, Sicherheit, Rendering).</a:t>
-            </a:r>
-          </a:p>
-        </p:txBody>
-      </p:sp>
-    </p:spTree>
-  </p:cSld>
-  <p:clrMapOvr>
-    <a:masterClrMapping/>
-  </p:clrMapOvr>
-</p:sld>
-</file>
-
-<file path=ppt/slides/slide8.xml><?xml version="1.0" encoding="utf-8"?>
-<p:sld xmlns:a="http://schemas.openxmlformats.org/drawingml/2006/main" xmlns:p="http://schemas.openxmlformats.org/presentationml/2006/main" xmlns:r="http://schemas.openxmlformats.org/officeDocument/2006/relationships">
-  <p:cSld>
-    <p:spTree>
-      <p:nvGrpSpPr>
-        <p:cNvPr id="1" name=""/>
-        <p:cNvGrpSpPr/>
-        <p:nvPr/>
-      </p:nvGrpSpPr>
-      <p:grpSpPr/>
-      <p:sp>
-        <p:nvSpPr>
-          <p:cNvPr id="2" name="Title 1"/>
-          <p:cNvSpPr>
-            <a:spLocks noGrp="1"/>
-          </p:cNvSpPr>
-          <p:nvPr>
-            <p:ph type="title"/>
-          </p:nvPr>
-        </p:nvSpPr>
-        <p:spPr/>
-        <p:txBody>
-          <a:bodyPr/>
-          <a:lstStyle/>
-          <a:p>
-            <a:pPr algn="l"/>
-            <a:r>
-              <a:rPr sz="2800" b="1">
-                <a:solidFill>
-                  <a:srgbClr val="38B07D"/>
-                </a:solidFill>
-              </a:rPr>
-              <a:t>DOCX — XML, aber das falsche</a:t>
-            </a:r>
-          </a:p>
-        </p:txBody>
-      </p:sp>
-      <p:sp>
-        <p:nvSpPr>
-          <p:cNvPr id="3" name="Content Placeholder 2"/>
-          <p:cNvSpPr>
-            <a:spLocks noGrp="1"/>
-          </p:cNvSpPr>
-          <p:nvPr>
-            <p:ph idx="1"/>
-          </p:nvPr>
-        </p:nvSpPr>
-        <p:spPr/>
-        <p:txBody>
-          <a:bodyPr/>
-          <a:lstStyle/>
-          <a:p/>
-        </p:txBody>
-      </p:sp>
-      <p:sp>
-        <p:nvSpPr>
-          <p:cNvPr id="4" name="Text Placeholder 3"/>
-          <p:cNvSpPr>
-            <a:spLocks noGrp="1"/>
-          </p:cNvSpPr>
-          <p:nvPr>
-            <p:ph type="body" idx="2" sz="half"/>
-          </p:nvPr>
-        </p:nvSpPr>
-        <p:spPr/>
-        <p:txBody>
-          <a:bodyPr wrap="square"/>
-          <a:lstStyle/>
-          <a:p>
-            <a:pPr/>
-            <a:r>
-              <a:rPr sz="1800">
-                <a:solidFill>
-                  <a:srgbClr val="212121"/>
-                </a:solidFill>
-              </a:rPr>
-              <a:t>DOCX ist intern XML (Office Open XML, ZIP-Container).</a:t>
-            </a:r>
-          </a:p>
-          <a:p>
-            <a:pPr/>
-            <a:r>
-              <a:rPr sz="1800">
-                <a:solidFill>
-                  <a:srgbClr val="212121"/>
-                </a:solidFill>
-              </a:rPr>
-              <a:t>Aber: generisches Textverarbeitungs-Modell — kein Domänen-Modell.</a:t>
-            </a:r>
-          </a:p>
-          <a:p>
-            <a:pPr lvl="1"/>
-            <a:r>
-              <a:rPr sz="1600">
-                <a:solidFill>
-                  <a:srgbClr val="212121"/>
-                </a:solidFill>
-              </a:rPr>
-              <a:t>Konzepte: Absatz, Stilvorlage, Tabelle.</a:t>
-            </a:r>
-          </a:p>
-          <a:p>
-            <a:pPr lvl="1"/>
-            <a:r>
-              <a:rPr sz="1600">
-                <a:solidFill>
-                  <a:srgbClr val="212121"/>
-                </a:solidFill>
-              </a:rPr>
-              <a:t>Nicht: Erwägung, Geschäftsnummer, Rechtsbegehren.</a:t>
-            </a:r>
-          </a:p>
-          <a:p>
-            <a:pPr/>
-            <a:r>
-              <a:rPr sz="1800">
-                <a:solidFill>
-                  <a:srgbClr val="212121"/>
-                </a:solidFill>
-              </a:rPr>
-              <a:t>OOXML validiert die Layout-Struktur, nicht den juristischen Inhalt.</a:t>
-            </a:r>
-          </a:p>
-          <a:p>
-            <a:pPr/>
-            <a:r>
-              <a:rPr sz="1800">
-                <a:solidFill>
-                  <a:srgbClr val="212121"/>
-                </a:solidFill>
-              </a:rPr>
-              <a:t>ZIP-Container — nicht direkt diff-bar in Versionskontrolle.</a:t>
-            </a:r>
-          </a:p>
-        </p:txBody>
-      </p:sp>
-    </p:spTree>
-  </p:cSld>
-  <p:clrMapOvr>
-    <a:masterClrMapping/>
-  </p:clrMapOvr>
-</p:sld>
-</file>
-
-<file path=ppt/slides/slide9.xml><?xml version="1.0" encoding="utf-8"?>
-<p:sld xmlns:a="http://schemas.openxmlformats.org/drawingml/2006/main" xmlns:p="http://schemas.openxmlformats.org/presentationml/2006/main" xmlns:r="http://schemas.openxmlformats.org/officeDocument/2006/relationships">
-  <p:cSld>
-    <p:spTree>
-      <p:nvGrpSpPr>
-        <p:cNvPr id="1" name=""/>
-        <p:cNvGrpSpPr/>
-        <p:nvPr/>
-      </p:nvGrpSpPr>
-      <p:grpSpPr/>
-      <p:sp>
-        <p:nvSpPr>
-          <p:cNvPr id="2" name="Title 1"/>
-          <p:cNvSpPr>
-            <a:spLocks noGrp="1"/>
-          </p:cNvSpPr>
-          <p:nvPr>
-            <p:ph type="title"/>
-          </p:nvPr>
-        </p:nvSpPr>
-        <p:spPr/>
-        <p:txBody>
-          <a:bodyPr/>
-          <a:lstStyle/>
-          <a:p>
-            <a:pPr algn="l"/>
-            <a:r>
-              <a:rPr sz="4000" b="1">
-                <a:solidFill>
-                  <a:srgbClr val="38B07D"/>
-                </a:solidFill>
-              </a:rPr>
-              <a:t>Vorteile von Domänen-XML</a:t>
-            </a:r>
-          </a:p>
-        </p:txBody>
-      </p:sp>
     </p:spTree>
   </p:cSld>
   <p:clrMapOvr>

</xml_diff>